<commit_message>
Actualizacion Licencias y Cuadernillos
</commit_message>
<xml_diff>
--- a/04-capacitacion/Capacitacion-Evaluadores-Rubrica-STEAM.pptx
+++ b/04-capacitacion/Capacitacion-Evaluadores-Rubrica-STEAM.pptx
@@ -10751,8 +10751,8 @@
         </p:nvSpPr>
         <p:spPr>
           <a:xfrm>
-            <a:off x="640080" y="3063240"/>
-            <a:ext cx="4937760" cy="2743200"/>
+            <a:off x="640080" y="3017520"/>
+            <a:ext cx="4937760" cy="2834640"/>
           </a:xfrm>
           <a:prstGeom prst="rect">
             <a:avLst/>
@@ -10766,12 +10766,12 @@
           <a:p>
             <a:pPr indent="0" marL="0">
               <a:lnSpc>
-                <a:spcPts val="1500"/>
-              </a:lnSpc>
-              <a:buNone/>
-            </a:pPr>
-            <a:r>
-              <a:rPr lang="en-US" sz="1150" dirty="0">
+                <a:spcPts val="1300"/>
+              </a:lnSpc>
+              <a:buNone/>
+            </a:pPr>
+            <a:r>
+              <a:rPr lang="en-US" sz="1000" dirty="0">
                 <a:solidFill>
                   <a:srgbClr val="FFFFFF"/>
                 </a:solidFill>
@@ -10781,17 +10781,17 @@
               </a:rPr>
               <a:t>Diseño y desarrollo</a:t>
             </a:r>
-            <a:endParaRPr lang="en-US" sz="1150" dirty="0"/>
-          </a:p>
-          <a:p>
-            <a:pPr indent="0" marL="0">
-              <a:lnSpc>
-                <a:spcPts val="1500"/>
-              </a:lnSpc>
-              <a:buNone/>
-            </a:pPr>
-            <a:r>
-              <a:rPr lang="en-US" sz="1150" dirty="0">
+            <a:endParaRPr lang="en-US" sz="1000" dirty="0"/>
+          </a:p>
+          <a:p>
+            <a:pPr indent="0" marL="0">
+              <a:lnSpc>
+                <a:spcPts val="1300"/>
+              </a:lnSpc>
+              <a:buNone/>
+            </a:pPr>
+            <a:r>
+              <a:rPr lang="en-US" sz="1000" dirty="0">
                 <a:solidFill>
                   <a:srgbClr val="FFFFFF"/>
                 </a:solidFill>
@@ -10801,26 +10801,26 @@
               </a:rPr>
               <a:t>Dr. Emmanuelle Ruelas Gómez</a:t>
             </a:r>
-            <a:endParaRPr lang="en-US" sz="1150" dirty="0"/>
-          </a:p>
-          <a:p>
-            <a:pPr indent="0" marL="0">
-              <a:lnSpc>
-                <a:spcPts val="1500"/>
-              </a:lnSpc>
-              <a:buNone/>
-            </a:pPr>
-            <a:endParaRPr lang="en-US" sz="1150" dirty="0"/>
-          </a:p>
-          <a:p>
-            <a:pPr indent="0" marL="0">
-              <a:lnSpc>
-                <a:spcPts val="1500"/>
-              </a:lnSpc>
-              <a:buNone/>
-            </a:pPr>
-            <a:r>
-              <a:rPr lang="en-US" sz="1150" dirty="0">
+            <a:endParaRPr lang="en-US" sz="1000" dirty="0"/>
+          </a:p>
+          <a:p>
+            <a:pPr indent="0" marL="0">
+              <a:lnSpc>
+                <a:spcPts val="1300"/>
+              </a:lnSpc>
+              <a:buNone/>
+            </a:pPr>
+            <a:endParaRPr lang="en-US" sz="1000" dirty="0"/>
+          </a:p>
+          <a:p>
+            <a:pPr indent="0" marL="0">
+              <a:lnSpc>
+                <a:spcPts val="1300"/>
+              </a:lnSpc>
+              <a:buNone/>
+            </a:pPr>
+            <a:r>
+              <a:rPr lang="en-US" sz="1000" dirty="0">
                 <a:solidFill>
                   <a:srgbClr val="FFFFFF"/>
                 </a:solidFill>
@@ -10830,17 +10830,17 @@
               </a:rPr>
               <a:t>Contenido pedagógico</a:t>
             </a:r>
-            <a:endParaRPr lang="en-US" sz="1150" dirty="0"/>
-          </a:p>
-          <a:p>
-            <a:pPr indent="0" marL="0">
-              <a:lnSpc>
-                <a:spcPts val="1500"/>
-              </a:lnSpc>
-              <a:buNone/>
-            </a:pPr>
-            <a:r>
-              <a:rPr lang="en-US" sz="1150" dirty="0">
+            <a:endParaRPr lang="en-US" sz="1000" dirty="0"/>
+          </a:p>
+          <a:p>
+            <a:pPr indent="0" marL="0">
+              <a:lnSpc>
+                <a:spcPts val="1300"/>
+              </a:lnSpc>
+              <a:buNone/>
+            </a:pPr>
+            <a:r>
+              <a:rPr lang="en-US" sz="1000" dirty="0">
                 <a:solidFill>
                   <a:srgbClr val="FFFFFF"/>
                 </a:solidFill>
@@ -10848,19 +10848,19 @@
                 <a:ea typeface="Arial" pitchFamily="34" charset="-122"/>
                 <a:cs typeface="Arial" pitchFamily="34" charset="-120"/>
               </a:rPr>
-              <a:t>Dr. Emmanuelle Ruelas Gómez, Ing. Daniel Millan Alcantara,</a:t>
-            </a:r>
-            <a:endParaRPr lang="en-US" sz="1150" dirty="0"/>
-          </a:p>
-          <a:p>
-            <a:pPr indent="0" marL="0">
-              <a:lnSpc>
-                <a:spcPts val="1500"/>
-              </a:lnSpc>
-              <a:buNone/>
-            </a:pPr>
-            <a:r>
-              <a:rPr lang="en-US" sz="1150" dirty="0">
+              <a:t>Dr. Emmanuelle Ruelas Gómez, Ing. Daniel Millan Coronado,</a:t>
+            </a:r>
+            <a:endParaRPr lang="en-US" sz="1000" dirty="0"/>
+          </a:p>
+          <a:p>
+            <a:pPr indent="0" marL="0">
+              <a:lnSpc>
+                <a:spcPts val="1300"/>
+              </a:lnSpc>
+              <a:buNone/>
+            </a:pPr>
+            <a:r>
+              <a:rPr lang="en-US" sz="1000" dirty="0">
                 <a:solidFill>
                   <a:srgbClr val="FFFFFF"/>
                 </a:solidFill>
@@ -10868,28 +10868,19 @@
                 <a:ea typeface="Arial" pitchFamily="34" charset="-122"/>
                 <a:cs typeface="Arial" pitchFamily="34" charset="-120"/>
               </a:rPr>
-              <a:t>Mtra. Emarinia Angulo Camacho, Mtra. Miriam Melero Hernández</a:t>
-            </a:r>
-            <a:endParaRPr lang="en-US" sz="1150" dirty="0"/>
-          </a:p>
-          <a:p>
-            <a:pPr indent="0" marL="0">
-              <a:lnSpc>
-                <a:spcPts val="1500"/>
-              </a:lnSpc>
-              <a:buNone/>
-            </a:pPr>
-            <a:endParaRPr lang="en-US" sz="1150" dirty="0"/>
-          </a:p>
-          <a:p>
-            <a:pPr indent="0" marL="0">
-              <a:lnSpc>
-                <a:spcPts val="1500"/>
-              </a:lnSpc>
-              <a:buNone/>
-            </a:pPr>
-            <a:r>
-              <a:rPr lang="en-US" sz="1150" dirty="0">
+              <a:t>Mtra. Emarinia Angulo Camacho, Mtra. Miriam Melero Hernández,</a:t>
+            </a:r>
+            <a:endParaRPr lang="en-US" sz="1000" dirty="0"/>
+          </a:p>
+          <a:p>
+            <a:pPr indent="0" marL="0">
+              <a:lnSpc>
+                <a:spcPts val="1300"/>
+              </a:lnSpc>
+              <a:buNone/>
+            </a:pPr>
+            <a:r>
+              <a:rPr lang="en-US" sz="1000" dirty="0">
                 <a:solidFill>
                   <a:srgbClr val="FFFFFF"/>
                 </a:solidFill>
@@ -10897,19 +10888,48 @@
                 <a:ea typeface="Arial" pitchFamily="34" charset="-122"/>
                 <a:cs typeface="Arial" pitchFamily="34" charset="-120"/>
               </a:rPr>
+              <a:t>Dra. Silvia Lizeth Becerra Rojas, M en C. Maritza Patricia López Solorio</a:t>
+            </a:r>
+            <a:endParaRPr lang="en-US" sz="1000" dirty="0"/>
+          </a:p>
+          <a:p>
+            <a:pPr indent="0" marL="0">
+              <a:lnSpc>
+                <a:spcPts val="1300"/>
+              </a:lnSpc>
+              <a:buNone/>
+            </a:pPr>
+            <a:endParaRPr lang="en-US" sz="1000" dirty="0"/>
+          </a:p>
+          <a:p>
+            <a:pPr indent="0" marL="0">
+              <a:lnSpc>
+                <a:spcPts val="1300"/>
+              </a:lnSpc>
+              <a:buNone/>
+            </a:pPr>
+            <a:r>
+              <a:rPr lang="en-US" sz="1000" dirty="0">
+                <a:solidFill>
+                  <a:srgbClr val="FFFFFF"/>
+                </a:solidFill>
+                <a:latin typeface="Arial" pitchFamily="34" charset="0"/>
+                <a:ea typeface="Arial" pitchFamily="34" charset="-122"/>
+                <a:cs typeface="Arial" pitchFamily="34" charset="-120"/>
+              </a:rPr>
               <a:t>Revisión y validación</a:t>
             </a:r>
-            <a:endParaRPr lang="en-US" sz="1150" dirty="0"/>
-          </a:p>
-          <a:p>
-            <a:pPr indent="0" marL="0">
-              <a:lnSpc>
-                <a:spcPts val="1500"/>
-              </a:lnSpc>
-              <a:buNone/>
-            </a:pPr>
-            <a:r>
-              <a:rPr lang="en-US" sz="1150" dirty="0">
+            <a:endParaRPr lang="en-US" sz="1000" dirty="0"/>
+          </a:p>
+          <a:p>
+            <a:pPr indent="0" marL="0">
+              <a:lnSpc>
+                <a:spcPts val="1300"/>
+              </a:lnSpc>
+              <a:buNone/>
+            </a:pPr>
+            <a:r>
+              <a:rPr lang="en-US" sz="1000" dirty="0">
                 <a:solidFill>
                   <a:srgbClr val="FFFFFF"/>
                 </a:solidFill>
@@ -10919,26 +10939,26 @@
               </a:rPr>
               <a:t>Dr. Juan Terrazas Gaynor</a:t>
             </a:r>
-            <a:endParaRPr lang="en-US" sz="1150" dirty="0"/>
-          </a:p>
-          <a:p>
-            <a:pPr indent="0" marL="0">
-              <a:lnSpc>
-                <a:spcPts val="1500"/>
-              </a:lnSpc>
-              <a:buNone/>
-            </a:pPr>
-            <a:endParaRPr lang="en-US" sz="1150" dirty="0"/>
-          </a:p>
-          <a:p>
-            <a:pPr indent="0" marL="0">
-              <a:lnSpc>
-                <a:spcPts val="1500"/>
-              </a:lnSpc>
-              <a:buNone/>
-            </a:pPr>
-            <a:r>
-              <a:rPr lang="en-US" sz="1150" dirty="0">
+            <a:endParaRPr lang="en-US" sz="1000" dirty="0"/>
+          </a:p>
+          <a:p>
+            <a:pPr indent="0" marL="0">
+              <a:lnSpc>
+                <a:spcPts val="1300"/>
+              </a:lnSpc>
+              <a:buNone/>
+            </a:pPr>
+            <a:endParaRPr lang="en-US" sz="1000" dirty="0"/>
+          </a:p>
+          <a:p>
+            <a:pPr indent="0" marL="0">
+              <a:lnSpc>
+                <a:spcPts val="1300"/>
+              </a:lnSpc>
+              <a:buNone/>
+            </a:pPr>
+            <a:r>
+              <a:rPr lang="en-US" sz="1000" dirty="0">
                 <a:solidFill>
                   <a:srgbClr val="FFFFFF"/>
                 </a:solidFill>
@@ -10948,17 +10968,17 @@
               </a:rPr>
               <a:t>Gestión y eventos</a:t>
             </a:r>
-            <a:endParaRPr lang="en-US" sz="1150" dirty="0"/>
-          </a:p>
-          <a:p>
-            <a:pPr indent="0" marL="0">
-              <a:lnSpc>
-                <a:spcPts val="1500"/>
-              </a:lnSpc>
-              <a:buNone/>
-            </a:pPr>
-            <a:r>
-              <a:rPr lang="en-US" sz="1150" dirty="0">
+            <a:endParaRPr lang="en-US" sz="1000" dirty="0"/>
+          </a:p>
+          <a:p>
+            <a:pPr indent="0" marL="0">
+              <a:lnSpc>
+                <a:spcPts val="1300"/>
+              </a:lnSpc>
+              <a:buNone/>
+            </a:pPr>
+            <a:r>
+              <a:rPr lang="en-US" sz="1000" dirty="0">
                 <a:solidFill>
                   <a:srgbClr val="FFFFFF"/>
                 </a:solidFill>
@@ -10966,9 +10986,9 @@
                 <a:ea typeface="Arial" pitchFamily="34" charset="-122"/>
                 <a:cs typeface="Arial" pitchFamily="34" charset="-120"/>
               </a:rPr>
-              <a:t>Ing. Daniel Millan Alcantara, Dra. Verónica Rojas Mendizábal</a:t>
-            </a:r>
-            <a:endParaRPr lang="en-US" sz="1150" dirty="0"/>
+              <a:t>Ing. Daniel Millan Coronado, Dra. Verónica Rojas Mendizábal</a:t>
+            </a:r>
+            <a:endParaRPr lang="en-US" sz="1000" dirty="0"/>
           </a:p>
         </p:txBody>
       </p:sp>

</xml_diff>